<commit_message>
Polish layout, add delivery guide and QA, archive obsolete PDF
</commit_message>
<xml_diff>
--- a/02_答辩PPT/智骨云析_AIC答辩PPT.pptx
+++ b/02_答辩PPT/智骨云析_AIC答辩PPT.pptx
@@ -5636,7 +5636,7 @@
 </file>
 
 <file path=ppt/slides/slide12.xml><?xml version="1.0" encoding="utf-8"?>
-<p:sld xmlns:a="http://schemas.openxmlformats.org/drawingml/2006/main" xmlns:r="http://schemas.openxmlformats.org/officeDocument/2006/relationships" xmlns:p="http://schemas.openxmlformats.org/presentationml/2006/main">
+<p:sld xmlns:a="http://schemas.openxmlformats.org/drawingml/2006/main" xmlns:p="http://schemas.openxmlformats.org/presentationml/2006/main">
   <p:cSld name="Slide 12">
     <p:bg>
       <p:bgPr>
@@ -6318,8 +6318,8 @@
         </p:nvSpPr>
         <p:spPr>
           <a:xfrm>
-            <a:off x="749808" y="3709264"/>
-            <a:ext cx="832104" cy="237744"/>
+            <a:off x="809244" y="3709264"/>
+            <a:ext cx="713232" cy="237744"/>
           </a:xfrm>
           <a:prstGeom prst="rect">
             <a:avLst/>
@@ -6387,8 +6387,8 @@
         </p:nvSpPr>
         <p:spPr>
           <a:xfrm>
-            <a:off x="1517904" y="2862163"/>
-            <a:ext cx="832104" cy="237744"/>
+            <a:off x="1577340" y="2862163"/>
+            <a:ext cx="713232" cy="237744"/>
           </a:xfrm>
           <a:prstGeom prst="rect">
             <a:avLst/>
@@ -6500,8 +6500,8 @@
         </p:nvSpPr>
         <p:spPr>
           <a:xfrm>
-            <a:off x="3172968" y="4096329"/>
-            <a:ext cx="832104" cy="237744"/>
+            <a:off x="3232404" y="4096329"/>
+            <a:ext cx="713232" cy="237744"/>
           </a:xfrm>
           <a:prstGeom prst="rect">
             <a:avLst/>
@@ -6569,8 +6569,8 @@
         </p:nvSpPr>
         <p:spPr>
           <a:xfrm>
-            <a:off x="3941064" y="2881640"/>
-            <a:ext cx="832104" cy="237744"/>
+            <a:off x="4000500" y="2881640"/>
+            <a:ext cx="713232" cy="237744"/>
           </a:xfrm>
           <a:prstGeom prst="rect">
             <a:avLst/>
@@ -6682,8 +6682,8 @@
         </p:nvSpPr>
         <p:spPr>
           <a:xfrm>
-            <a:off x="5596128" y="2655600"/>
-            <a:ext cx="832104" cy="237744"/>
+            <a:off x="5655564" y="2655600"/>
+            <a:ext cx="713232" cy="237744"/>
           </a:xfrm>
           <a:prstGeom prst="rect">
             <a:avLst/>
@@ -6751,8 +6751,8 @@
         </p:nvSpPr>
         <p:spPr>
           <a:xfrm>
-            <a:off x="6364224" y="2776576"/>
-            <a:ext cx="832104" cy="237744"/>
+            <a:off x="6423660" y="2776576"/>
+            <a:ext cx="713232" cy="237744"/>
           </a:xfrm>
           <a:prstGeom prst="rect">
             <a:avLst/>
@@ -8996,7 +8996,7 @@
 </file>
 
 <file path=ppt/slides/slide15.xml><?xml version="1.0" encoding="utf-8"?>
-<p:sld xmlns:a="http://schemas.openxmlformats.org/drawingml/2006/main" xmlns:r="http://schemas.openxmlformats.org/officeDocument/2006/relationships" xmlns:p="http://schemas.openxmlformats.org/presentationml/2006/main">
+<p:sld xmlns:a="http://schemas.openxmlformats.org/drawingml/2006/main" xmlns:p="http://schemas.openxmlformats.org/presentationml/2006/main" xmlns:r="http://schemas.openxmlformats.org/officeDocument/2006/relationships">
   <p:cSld name="Slide 15">
     <p:bg>
       <p:bgPr>
@@ -9785,8 +9785,8 @@
                 <a:solidFill>
                   <a:srgbClr val="087F83"/>
                 </a:solidFill>
-                <a:latin typeface="Aptos" pitchFamily="34" charset="0"/>
-                <a:ea typeface="Aptos" pitchFamily="34" charset="-122"/>
+                <a:latin typeface="Microsoft YaHei" pitchFamily="34" charset="0"/>
+                <a:ea typeface="Microsoft YaHei" pitchFamily="34" charset="-122"/>
                 <a:cs typeface="Aptos" pitchFamily="34" charset="-120"/>
               </a:rPr>
               <a:t>1.5 mm 聚类 · 工程 vertex-HD95 0.607 mm</a:t>
@@ -13778,7 +13778,7 @@
 </file>
 
 <file path=ppt/slides/slide2.xml><?xml version="1.0" encoding="utf-8"?>
-<p:sld xmlns:a="http://schemas.openxmlformats.org/drawingml/2006/main" xmlns:r="http://schemas.openxmlformats.org/officeDocument/2006/relationships" xmlns:p="http://schemas.openxmlformats.org/presentationml/2006/main">
+<p:sld xmlns:a="http://schemas.openxmlformats.org/drawingml/2006/main" xmlns:p="http://schemas.openxmlformats.org/presentationml/2006/main" xmlns:r="http://schemas.openxmlformats.org/officeDocument/2006/relationships">
   <p:cSld name="Slide 2">
     <p:bg>
       <p:bgPr>
@@ -14141,7 +14141,7 @@
         <p:spPr>
           <a:xfrm>
             <a:off x="1234440" y="1984248"/>
-            <a:ext cx="1828800" cy="402336"/>
+            <a:ext cx="1645920" cy="402336"/>
           </a:xfrm>
           <a:prstGeom prst="rect">
             <a:avLst/>
@@ -14340,7 +14340,7 @@
         <p:spPr>
           <a:xfrm>
             <a:off x="1234440" y="3218688"/>
-            <a:ext cx="1828800" cy="402336"/>
+            <a:ext cx="1645920" cy="402336"/>
           </a:xfrm>
           <a:prstGeom prst="rect">
             <a:avLst/>
@@ -14539,7 +14539,7 @@
         <p:spPr>
           <a:xfrm>
             <a:off x="1234440" y="4453128"/>
-            <a:ext cx="1828800" cy="402336"/>
+            <a:ext cx="1645920" cy="402336"/>
           </a:xfrm>
           <a:prstGeom prst="rect">
             <a:avLst/>
@@ -24474,7 +24474,7 @@
 </file>
 
 <file path=ppt/slides/slide6.xml><?xml version="1.0" encoding="utf-8"?>
-<p:sld xmlns:a="http://schemas.openxmlformats.org/drawingml/2006/main" xmlns:r="http://schemas.openxmlformats.org/officeDocument/2006/relationships" xmlns:p="http://schemas.openxmlformats.org/presentationml/2006/main">
+<p:sld xmlns:a="http://schemas.openxmlformats.org/drawingml/2006/main" xmlns:p="http://schemas.openxmlformats.org/presentationml/2006/main">
   <p:cSld name="Slide 6">
     <p:bg>
       <p:bgPr>
@@ -25082,7 +25082,7 @@
         <p:spPr>
           <a:xfrm>
             <a:off x="6684264" y="2459736"/>
-            <a:ext cx="4782312" cy="804672"/>
+            <a:ext cx="4782312" cy="731520"/>
           </a:xfrm>
           <a:prstGeom prst="rect">
             <a:avLst/>
@@ -25214,7 +25214,7 @@
         <p:spPr>
           <a:xfrm>
             <a:off x="6684264" y="3712464"/>
-            <a:ext cx="4782312" cy="804672"/>
+            <a:ext cx="4782312" cy="731520"/>
           </a:xfrm>
           <a:prstGeom prst="rect">
             <a:avLst/>
@@ -26681,7 +26681,7 @@
 </file>
 
 <file path=ppt/slides/slide8.xml><?xml version="1.0" encoding="utf-8"?>
-<p:sld xmlns:a="http://schemas.openxmlformats.org/drawingml/2006/main" xmlns:r="http://schemas.openxmlformats.org/officeDocument/2006/relationships" xmlns:p="http://schemas.openxmlformats.org/presentationml/2006/main">
+<p:sld xmlns:a="http://schemas.openxmlformats.org/drawingml/2006/main" xmlns:p="http://schemas.openxmlformats.org/presentationml/2006/main">
   <p:cSld name="Slide 8">
     <p:bg>
       <p:bgPr>
@@ -27766,8 +27766,8 @@
                 <a:solidFill>
                   <a:srgbClr val="087F83"/>
                 </a:solidFill>
-                <a:latin typeface="Aptos" pitchFamily="34" charset="0"/>
-                <a:ea typeface="Aptos" pitchFamily="34" charset="-122"/>
+                <a:latin typeface="Microsoft YaHei" pitchFamily="34" charset="0"/>
+                <a:ea typeface="Microsoft YaHei" pitchFamily="34" charset="-122"/>
                 <a:cs typeface="Aptos" pitchFamily="34" charset="-120"/>
               </a:rPr>
               <a:t>共享 evaluation_id + case_id</a:t>

</xml_diff>